<commit_message>
chore: refresh 24 APR docs (TPFDD/RFF/NAI/Roster minor updates)
LTC Sheaf 24 APR email returned the four working documents
"saved with the most current date." Actual diffs are small:

- Mission Roster: no content change (filename only)
- TPFDD: "Rest" -> "Reset" typo fix in status-code legend
- RFF/RFS: QRF task now "subordinate to the incident commander"
  (was "commander"); SECFOR screen description wording tweak
- NAI Graphics: SECFOR Patrol Ops slide annotated with approx.
  distances ~2200 m and ~2700 m from the ICP

Source files at /docs/source/ replaced in-place. Comms log
entry added. Ops Graphics page notes the new distance
annotations under SECFOR posture.

Co-Authored-By: Claude Opus 4.6 (1M context) <noreply@anthropic.com>
</commit_message>
<xml_diff>
--- a/site/docs/source/OPS-NAI-Graphics.pptx
+++ b/site/docs/source/OPS-NAI-Graphics.pptx
@@ -215,7 +215,7 @@
           <a:p>
             <a:fld id="{C643A962-1FD4-4C83-A809-27EA9E9230E6}" type="datetimeFigureOut">
               <a:rPr lang="en-US" smtClean="0"/>
-              <a:t>4/21/2026</a:t>
+              <a:t>4/22/2026</a:t>
             </a:fld>
             <a:endParaRPr lang="en-US"/>
           </a:p>
@@ -1457,7 +1457,7 @@
           <a:p>
             <a:fld id="{8D392E4A-9BBD-4BA9-88BA-F92D78D6CF9B}" type="datetimeFigureOut">
               <a:rPr lang="en-US" smtClean="0"/>
-              <a:t>4/21/2026</a:t>
+              <a:t>4/22/2026</a:t>
             </a:fld>
             <a:endParaRPr lang="en-US"/>
           </a:p>
@@ -1655,7 +1655,7 @@
           <a:p>
             <a:fld id="{8D392E4A-9BBD-4BA9-88BA-F92D78D6CF9B}" type="datetimeFigureOut">
               <a:rPr lang="en-US" smtClean="0"/>
-              <a:t>4/21/2026</a:t>
+              <a:t>4/22/2026</a:t>
             </a:fld>
             <a:endParaRPr lang="en-US"/>
           </a:p>
@@ -1863,7 +1863,7 @@
           <a:p>
             <a:fld id="{8D392E4A-9BBD-4BA9-88BA-F92D78D6CF9B}" type="datetimeFigureOut">
               <a:rPr lang="en-US" smtClean="0"/>
-              <a:t>4/21/2026</a:t>
+              <a:t>4/22/2026</a:t>
             </a:fld>
             <a:endParaRPr lang="en-US"/>
           </a:p>
@@ -2061,7 +2061,7 @@
           <a:p>
             <a:fld id="{8D392E4A-9BBD-4BA9-88BA-F92D78D6CF9B}" type="datetimeFigureOut">
               <a:rPr lang="en-US" smtClean="0"/>
-              <a:t>4/21/2026</a:t>
+              <a:t>4/22/2026</a:t>
             </a:fld>
             <a:endParaRPr lang="en-US"/>
           </a:p>
@@ -2336,7 +2336,7 @@
           <a:p>
             <a:fld id="{8D392E4A-9BBD-4BA9-88BA-F92D78D6CF9B}" type="datetimeFigureOut">
               <a:rPr lang="en-US" smtClean="0"/>
-              <a:t>4/21/2026</a:t>
+              <a:t>4/22/2026</a:t>
             </a:fld>
             <a:endParaRPr lang="en-US"/>
           </a:p>
@@ -2601,7 +2601,7 @@
           <a:p>
             <a:fld id="{8D392E4A-9BBD-4BA9-88BA-F92D78D6CF9B}" type="datetimeFigureOut">
               <a:rPr lang="en-US" smtClean="0"/>
-              <a:t>4/21/2026</a:t>
+              <a:t>4/22/2026</a:t>
             </a:fld>
             <a:endParaRPr lang="en-US"/>
           </a:p>
@@ -3013,7 +3013,7 @@
           <a:p>
             <a:fld id="{8D392E4A-9BBD-4BA9-88BA-F92D78D6CF9B}" type="datetimeFigureOut">
               <a:rPr lang="en-US" smtClean="0"/>
-              <a:t>4/21/2026</a:t>
+              <a:t>4/22/2026</a:t>
             </a:fld>
             <a:endParaRPr lang="en-US"/>
           </a:p>
@@ -3154,7 +3154,7 @@
           <a:p>
             <a:fld id="{8D392E4A-9BBD-4BA9-88BA-F92D78D6CF9B}" type="datetimeFigureOut">
               <a:rPr lang="en-US" smtClean="0"/>
-              <a:t>4/21/2026</a:t>
+              <a:t>4/22/2026</a:t>
             </a:fld>
             <a:endParaRPr lang="en-US"/>
           </a:p>
@@ -3267,7 +3267,7 @@
           <a:p>
             <a:fld id="{8D392E4A-9BBD-4BA9-88BA-F92D78D6CF9B}" type="datetimeFigureOut">
               <a:rPr lang="en-US" smtClean="0"/>
-              <a:t>4/21/2026</a:t>
+              <a:t>4/22/2026</a:t>
             </a:fld>
             <a:endParaRPr lang="en-US"/>
           </a:p>
@@ -3578,7 +3578,7 @@
           <a:p>
             <a:fld id="{8D392E4A-9BBD-4BA9-88BA-F92D78D6CF9B}" type="datetimeFigureOut">
               <a:rPr lang="en-US" smtClean="0"/>
-              <a:t>4/21/2026</a:t>
+              <a:t>4/22/2026</a:t>
             </a:fld>
             <a:endParaRPr lang="en-US"/>
           </a:p>
@@ -3866,7 +3866,7 @@
           <a:p>
             <a:fld id="{8D392E4A-9BBD-4BA9-88BA-F92D78D6CF9B}" type="datetimeFigureOut">
               <a:rPr lang="en-US" smtClean="0"/>
-              <a:t>4/21/2026</a:t>
+              <a:t>4/22/2026</a:t>
             </a:fld>
             <a:endParaRPr lang="en-US"/>
           </a:p>
@@ -4107,7 +4107,7 @@
           <a:p>
             <a:fld id="{8D392E4A-9BBD-4BA9-88BA-F92D78D6CF9B}" type="datetimeFigureOut">
               <a:rPr lang="en-US" smtClean="0"/>
-              <a:t>4/21/2026</a:t>
+              <a:t>4/22/2026</a:t>
             </a:fld>
             <a:endParaRPr lang="en-US"/>
           </a:p>
@@ -9098,6 +9098,198 @@
                 <a:cs typeface="Times New Roman" panose="02020603050405020304" pitchFamily="18" charset="0"/>
               </a:rPr>
               <a:t>SECFOR Patrol Ops</a:t>
+            </a:r>
+          </a:p>
+        </p:txBody>
+      </p:sp>
+      <p:sp>
+        <p:nvSpPr>
+          <p:cNvPr id="15" name="TextBox 14">
+            <a:extLst>
+              <a:ext uri="{FF2B5EF4-FFF2-40B4-BE49-F238E27FC236}">
+                <a16:creationId xmlns:a16="http://schemas.microsoft.com/office/drawing/2014/main" id="{1B8FBC90-0736-0F93-E811-383BF1B32DD3}"/>
+              </a:ext>
+            </a:extLst>
+          </p:cNvPr>
+          <p:cNvSpPr txBox="1"/>
+          <p:nvPr/>
+        </p:nvSpPr>
+        <p:spPr>
+          <a:xfrm rot="19751697">
+            <a:off x="4296452" y="2269775"/>
+            <a:ext cx="777777" cy="276999"/>
+          </a:xfrm>
+          <a:prstGeom prst="rect">
+            <a:avLst/>
+          </a:prstGeom>
+          <a:solidFill>
+            <a:schemeClr val="bg1"/>
+          </a:solidFill>
+          <a:ln w="38100">
+            <a:solidFill>
+              <a:srgbClr val="FF0000"/>
+            </a:solidFill>
+          </a:ln>
+        </p:spPr>
+        <p:txBody>
+          <a:bodyPr wrap="none" rtlCol="0">
+            <a:spAutoFit/>
+          </a:bodyPr>
+          <a:lstStyle/>
+          <a:p>
+            <a:r>
+              <a:rPr lang="en-US" sz="1200" b="1" dirty="0">
+                <a:solidFill>
+                  <a:srgbClr val="FF0000"/>
+                </a:solidFill>
+                <a:latin typeface="Times New Roman" panose="02020603050405020304" pitchFamily="18" charset="0"/>
+                <a:cs typeface="Times New Roman" panose="02020603050405020304" pitchFamily="18" charset="0"/>
+              </a:rPr>
+              <a:t>~ 2700 m</a:t>
+            </a:r>
+          </a:p>
+        </p:txBody>
+      </p:sp>
+      <p:sp>
+        <p:nvSpPr>
+          <p:cNvPr id="16" name="TextBox 15">
+            <a:extLst>
+              <a:ext uri="{FF2B5EF4-FFF2-40B4-BE49-F238E27FC236}">
+                <a16:creationId xmlns:a16="http://schemas.microsoft.com/office/drawing/2014/main" id="{1545C867-275A-241F-E67A-BAD10F0BE41C}"/>
+              </a:ext>
+            </a:extLst>
+          </p:cNvPr>
+          <p:cNvSpPr txBox="1"/>
+          <p:nvPr/>
+        </p:nvSpPr>
+        <p:spPr>
+          <a:xfrm rot="1028481">
+            <a:off x="7411757" y="2649479"/>
+            <a:ext cx="777777" cy="276999"/>
+          </a:xfrm>
+          <a:prstGeom prst="rect">
+            <a:avLst/>
+          </a:prstGeom>
+          <a:solidFill>
+            <a:schemeClr val="bg1"/>
+          </a:solidFill>
+          <a:ln w="38100">
+            <a:solidFill>
+              <a:srgbClr val="FF0000"/>
+            </a:solidFill>
+          </a:ln>
+        </p:spPr>
+        <p:txBody>
+          <a:bodyPr wrap="none" rtlCol="0">
+            <a:spAutoFit/>
+          </a:bodyPr>
+          <a:lstStyle/>
+          <a:p>
+            <a:r>
+              <a:rPr lang="en-US" sz="1200" b="1" dirty="0">
+                <a:solidFill>
+                  <a:srgbClr val="FF0000"/>
+                </a:solidFill>
+                <a:latin typeface="Times New Roman" panose="02020603050405020304" pitchFamily="18" charset="0"/>
+                <a:cs typeface="Times New Roman" panose="02020603050405020304" pitchFamily="18" charset="0"/>
+              </a:rPr>
+              <a:t>~ 2200 m</a:t>
+            </a:r>
+          </a:p>
+        </p:txBody>
+      </p:sp>
+      <p:sp>
+        <p:nvSpPr>
+          <p:cNvPr id="17" name="TextBox 16">
+            <a:extLst>
+              <a:ext uri="{FF2B5EF4-FFF2-40B4-BE49-F238E27FC236}">
+                <a16:creationId xmlns:a16="http://schemas.microsoft.com/office/drawing/2014/main" id="{DF6A0F5D-84A2-9E5F-98FE-D002FBAEAA79}"/>
+              </a:ext>
+            </a:extLst>
+          </p:cNvPr>
+          <p:cNvSpPr txBox="1"/>
+          <p:nvPr/>
+        </p:nvSpPr>
+        <p:spPr>
+          <a:xfrm rot="20290655">
+            <a:off x="7479287" y="5495774"/>
+            <a:ext cx="777777" cy="276999"/>
+          </a:xfrm>
+          <a:prstGeom prst="rect">
+            <a:avLst/>
+          </a:prstGeom>
+          <a:solidFill>
+            <a:schemeClr val="bg1"/>
+          </a:solidFill>
+          <a:ln w="38100">
+            <a:solidFill>
+              <a:srgbClr val="FF0000"/>
+            </a:solidFill>
+          </a:ln>
+        </p:spPr>
+        <p:txBody>
+          <a:bodyPr wrap="none" rtlCol="0">
+            <a:spAutoFit/>
+          </a:bodyPr>
+          <a:lstStyle/>
+          <a:p>
+            <a:r>
+              <a:rPr lang="en-US" sz="1200" b="1" dirty="0">
+                <a:solidFill>
+                  <a:srgbClr val="FF0000"/>
+                </a:solidFill>
+                <a:latin typeface="Times New Roman" panose="02020603050405020304" pitchFamily="18" charset="0"/>
+                <a:cs typeface="Times New Roman" panose="02020603050405020304" pitchFamily="18" charset="0"/>
+              </a:rPr>
+              <a:t>~ 2200 m</a:t>
+            </a:r>
+          </a:p>
+        </p:txBody>
+      </p:sp>
+      <p:sp>
+        <p:nvSpPr>
+          <p:cNvPr id="18" name="TextBox 17">
+            <a:extLst>
+              <a:ext uri="{FF2B5EF4-FFF2-40B4-BE49-F238E27FC236}">
+                <a16:creationId xmlns:a16="http://schemas.microsoft.com/office/drawing/2014/main" id="{D734E6EB-98AF-C373-98EC-3A041F979F85}"/>
+              </a:ext>
+            </a:extLst>
+          </p:cNvPr>
+          <p:cNvSpPr txBox="1"/>
+          <p:nvPr/>
+        </p:nvSpPr>
+        <p:spPr>
+          <a:xfrm rot="1847095">
+            <a:off x="4870190" y="5333472"/>
+            <a:ext cx="777777" cy="276999"/>
+          </a:xfrm>
+          <a:prstGeom prst="rect">
+            <a:avLst/>
+          </a:prstGeom>
+          <a:solidFill>
+            <a:schemeClr val="bg1"/>
+          </a:solidFill>
+          <a:ln w="38100">
+            <a:solidFill>
+              <a:srgbClr val="FF0000"/>
+            </a:solidFill>
+          </a:ln>
+        </p:spPr>
+        <p:txBody>
+          <a:bodyPr wrap="none" rtlCol="0">
+            <a:spAutoFit/>
+          </a:bodyPr>
+          <a:lstStyle/>
+          <a:p>
+            <a:r>
+              <a:rPr lang="en-US" sz="1200" b="1" dirty="0">
+                <a:solidFill>
+                  <a:srgbClr val="FF0000"/>
+                </a:solidFill>
+                <a:latin typeface="Times New Roman" panose="02020603050405020304" pitchFamily="18" charset="0"/>
+                <a:cs typeface="Times New Roman" panose="02020603050405020304" pitchFamily="18" charset="0"/>
+              </a:rPr>
+              <a:t>~ 2200 m</a:t>
             </a:r>
           </a:p>
         </p:txBody>

</xml_diff>